<commit_message>
Explain Redefine scaling trends in concrete Japanese
</commit_message>
<xml_diff>
--- a/slides/datasets-in-10-minutes-redefine.pptx
+++ b/slides/datasets-in-10-minutes-redefine.pptx
@@ -11773,7 +11773,7 @@
                 <a:ea typeface="Noto Sans CJK JP"/>
                 <a:cs typeface="Noto Sans"/>
               </a:rPr>
-              <a:t>構築研究では、人が選んだ候補とデータの正解が一致するかを確認した。Redefineの一致率は100.0%だった。</a:t>
+              <a:t>構築時には、人が選んだ候補とデータの正解が一致するかを確認した。Redefineの一致率は100.0%だった。</a:t>
             </a:r>
           </a:p>
           <a:p>
@@ -12680,7 +12680,7 @@
                 <a:ea typeface="Noto Sans CJK JP"/>
                 <a:cs typeface="Noto Sans"/>
               </a:rPr>
-              <a:t>構築研究のゼロショット比較では、調べた全モデル系列で、最大モデルの成績が最小モデルより低かった。規模の途中での変化には揺れがある。</a:t>
+              <a:t>構築時のゼロショット比較では、調べた全モデル系列で、最大モデルの成績が最小モデルより低かった。規模の途中での変化には揺れがある。</a:t>
             </a:r>
           </a:p>
           <a:p>
@@ -13003,7 +13003,7 @@
                 <a:ea typeface="Noto Sans CJK JP"/>
                 <a:cs typeface="Noto Sans"/>
               </a:rPr>
-              <a:t>例示を増やすことで改善する課題もある一方、RedefineのGopher系列では、規模に対する逆方向または逆U字の傾向が残った。</a:t>
+              <a:t>例示を増やすことで改善する課題もある一方、RedefineのGopher系列では、モデルが大きくなるにつれて成績が下がる傾向や、いったん上がってから下がる傾向が残った。</a:t>
             </a:r>
           </a:p>
           <a:p>

</xml_diff>